<commit_message>
Investorenpräsentation (12 Folien) und gemeinsame Vorlage deck-lib.mjs
- plenara-investoren.pptx: Problem, Lösung, Stand heute, Produkt, plenara.X, Markt, Geschäftsmodell, Warum Plenara, Warum jetzt, nächste Schritte; Zahlen von plenara.de (15.10.26), Plan und Preise aus docs/strategie als Plan gekennzeichnet
- Vorlage (Thema, Layouts, Bausteine, Bilder) aus build-praesentation.mjs nach deck-lib.mjs gezogen; beide Fassungen bauen darauf
- corporate-design.md und brand.json: beide Fassungen und Befehle

Co-Authored-By: Claude Fable 5.1 <noreply@anthropic.com>
</commit_message>
<xml_diff>
--- a/docs/design/praesentation/plenara-firmenpraesentation.pptx
+++ b/docs/design/praesentation/plenara-firmenpraesentation.pptx
@@ -124,7 +124,7 @@
   <p:extLst>
     <p:ext uri="{521415D9-36F7-43E2-AB2F-B90AF26B5E84}">
       <p14:sectionLst xmlns:p14="http://schemas.microsoft.com/office/powerpoint/2010/main">
-        <p14:section name="Plenara" id="{26b048e4-35bb-749c-1727-94c571b8ad41}">
+        <p14:section name="Plenara" id="{53d43fb8-25a4-6fb8-bc51-50417cd6e39c}">
           <p14:sldIdLst>
             <p14:sldId id="256"/>
             <p14:sldId id="257"/>
@@ -138,7 +138,7 @@
             <p14:sldId id="265"/>
           </p14:sldIdLst>
         </p14:section>
-        <p14:section name="plenara.X" id="{666a210a-35f3-d8c9-2713-285982472809}">
+        <p14:section name="plenara.X" id="{50f31671-32e3-c918-6ce3-dacf6ddd1085}">
           <p14:sldIdLst>
             <p14:sldId id="266"/>
             <p14:sldId id="267"/>

</xml_diff>

<commit_message>
Investorenpräsentation mit Anwendungsfällen, Kennzahlen und Analysen; Branding auf Petrol klar
- plenara-investoren.pptx (20 Folien): Problem, Lösung, Kern (gelabelte, zusammengefasste, durchsuchbare Datenbank), Kennzahlen (8.113 Gemeinden, 85 % der Einwohner, 1,51 Mio. Vorgänge, Abdeckung je Bundesland), sechs Anwendungsfälle mit Screenshots der Seite (Redaktionen, Immobilien, Ausschreibungen, Versorgung, Verbände, Bürger), drei Analysen aus den öffentlichen Auszügen (Signale, Fakten und Beschlüsse, Trends und Beratungswege), Markt, Geschäftsmodell, nächste Schritte
- Vorlage deck-lib.mjs auf das Farbschema Petrol klar (tokens.css) umgestellt, Logos neu erzeugt, Produktfassung neu gebaut
- Screenshots der aktuellen Seite (22.10.26), screenshots.mjs mit Seitenliste; render-praesentation.mjs zeichnet Balken- und Säulendiagramme
- corporate-design.md Abschnitt 3 und brand.json: Petrol klar

Co-Authored-By: Claude Fable 5.1 <noreply@anthropic.com>
</commit_message>
<xml_diff>
--- a/docs/design/praesentation/plenara-firmenpraesentation.pptx
+++ b/docs/design/praesentation/plenara-firmenpraesentation.pptx
@@ -124,7 +124,7 @@
   <p:extLst>
     <p:ext uri="{521415D9-36F7-43E2-AB2F-B90AF26B5E84}">
       <p14:sectionLst xmlns:p14="http://schemas.microsoft.com/office/powerpoint/2010/main">
-        <p14:section name="Plenara" id="{53d43fb8-25a4-6fb8-bc51-50417cd6e39c}">
+        <p14:section name="Plenara" id="{55a6beff-22d2-b696-9ddb-8c2d016b84a0}">
           <p14:sldIdLst>
             <p14:sldId id="256"/>
             <p14:sldId id="257"/>
@@ -138,7 +138,7 @@
             <p14:sldId id="265"/>
           </p14:sldIdLst>
         </p14:section>
-        <p14:section name="plenara.X" id="{50f31671-32e3-c918-6ce3-dacf6ddd1085}">
+        <p14:section name="plenara.X" id="{d194a513-443e-79bc-4873-61fa683a9d13}">
           <p14:sldIdLst>
             <p14:sldId id="266"/>
             <p14:sldId id="267"/>
@@ -173,7 +173,7 @@
             <a:pPr algn="l">
               <a:defRPr sz="1100" b="0" i="0" u="none" strike="noStrike">
                 <a:solidFill>
-                  <a:srgbClr val="0F172A"/>
+                  <a:srgbClr val="18181B"/>
                 </a:solidFill>
                 <a:latin typeface="+mj-lt"/>
               </a:defRPr>
@@ -181,7 +181,7 @@
             <a:r>
               <a:rPr sz="1100" b="0" i="0" u="none" strike="noStrike">
                 <a:solidFill>
-                  <a:srgbClr val="0F172A"/>
+                  <a:srgbClr val="18181B"/>
                 </a:solidFill>
                 <a:latin typeface="+mj-lt"/>
               </a:rPr>
@@ -216,7 +216,7 @@
           </c:tx>
           <c:spPr>
             <a:solidFill>
-              <a:srgbClr val="0D9488"/>
+              <a:srgbClr val="268478"/>
             </a:solidFill>
             <a:effectLst/>
           </c:spPr>
@@ -230,7 +230,7 @@
                 <a:pPr>
                   <a:defRPr b="0" i="0" strike="noStrike" sz="1000" u="none">
                     <a:solidFill>
-                      <a:srgbClr val="0F172A"/>
+                      <a:srgbClr val="18181B"/>
                     </a:solidFill>
                     <a:latin typeface="+mn-lt"/>
                   </a:defRPr>
@@ -310,7 +310,7 @@
               <a:pPr>
                 <a:defRPr b="0" i="0" strike="noStrike" sz="1000" u="none">
                   <a:solidFill>
-                    <a:srgbClr val="0F172A"/>
+                    <a:srgbClr val="18181B"/>
                   </a:solidFill>
                   <a:latin typeface="+mn-lt"/>
                 </a:defRPr>
@@ -356,7 +356,7 @@
             <a:pPr>
               <a:defRPr sz="1000" b="0" i="0" u="none" strike="noStrike">
                 <a:solidFill>
-                  <a:srgbClr val="64748B"/>
+                  <a:srgbClr val="52525B"/>
                 </a:solidFill>
                 <a:latin typeface="+mn-lt"/>
               </a:defRPr>
@@ -383,7 +383,7 @@
           <c:spPr>
             <a:ln w="6350" cap="flat">
               <a:solidFill>
-                <a:srgbClr val="E2E8F0"/>
+                <a:srgbClr val="E4E4E7"/>
               </a:solidFill>
               <a:prstDash val="solid"/>
               <a:round/>
@@ -408,7 +408,7 @@
             <a:pPr>
               <a:defRPr sz="900" b="0" i="0" u="none" strike="noStrike">
                 <a:solidFill>
-                  <a:srgbClr val="94A3B8"/>
+                  <a:srgbClr val="A1A1AA"/>
                 </a:solidFill>
                 <a:latin typeface="+mn-lt"/>
               </a:defRPr>
@@ -459,7 +459,7 @@
             <a:pPr algn="l">
               <a:defRPr sz="1100" b="0" i="0" u="none" strike="noStrike">
                 <a:solidFill>
-                  <a:srgbClr val="0F172A"/>
+                  <a:srgbClr val="18181B"/>
                 </a:solidFill>
                 <a:latin typeface="+mj-lt"/>
               </a:defRPr>
@@ -467,7 +467,7 @@
             <a:r>
               <a:rPr sz="1100" b="0" i="0" u="none" strike="noStrike">
                 <a:solidFill>
-                  <a:srgbClr val="0F172A"/>
+                  <a:srgbClr val="18181B"/>
                 </a:solidFill>
                 <a:latin typeface="+mj-lt"/>
               </a:rPr>
@@ -502,7 +502,7 @@
           </c:tx>
           <c:spPr>
             <a:solidFill>
-              <a:srgbClr val="0D9488"/>
+              <a:srgbClr val="268478"/>
             </a:solidFill>
             <a:effectLst/>
           </c:spPr>
@@ -516,7 +516,7 @@
                 <a:pPr>
                   <a:defRPr b="0" i="0" strike="noStrike" sz="1000" u="none">
                     <a:solidFill>
-                      <a:srgbClr val="0F172A"/>
+                      <a:srgbClr val="18181B"/>
                     </a:solidFill>
                     <a:latin typeface="+mn-lt"/>
                   </a:defRPr>
@@ -596,7 +596,7 @@
               <a:pPr>
                 <a:defRPr b="0" i="0" strike="noStrike" sz="1000" u="none">
                   <a:solidFill>
-                    <a:srgbClr val="0F172A"/>
+                    <a:srgbClr val="18181B"/>
                   </a:solidFill>
                   <a:latin typeface="+mn-lt"/>
                 </a:defRPr>
@@ -642,7 +642,7 @@
             <a:pPr>
               <a:defRPr sz="1000" b="0" i="0" u="none" strike="noStrike">
                 <a:solidFill>
-                  <a:srgbClr val="64748B"/>
+                  <a:srgbClr val="52525B"/>
                 </a:solidFill>
                 <a:latin typeface="+mn-lt"/>
               </a:defRPr>
@@ -668,7 +668,7 @@
           <c:spPr>
             <a:ln w="6350" cap="flat">
               <a:solidFill>
-                <a:srgbClr val="E2E8F0"/>
+                <a:srgbClr val="E4E4E7"/>
               </a:solidFill>
               <a:prstDash val="solid"/>
               <a:round/>
@@ -693,7 +693,7 @@
             <a:pPr>
               <a:defRPr sz="900" b="0" i="0" u="none" strike="noStrike">
                 <a:solidFill>
-                  <a:srgbClr val="94A3B8"/>
+                  <a:srgbClr val="A1A1AA"/>
                 </a:solidFill>
                 <a:latin typeface="+mn-lt"/>
               </a:defRPr>
@@ -2733,7 +2733,7 @@
         <p:spPr>
           <a:xfrm>
             <a:off x="457200" y="4773168"/>
-            <a:ext cx="542536" cy="182880"/>
+            <a:ext cx="493160" cy="182880"/>
           </a:xfrm>
           <a:prstGeom prst="rect">
             <a:avLst/>
@@ -2851,7 +2851,7 @@
             <a:lvl1pPr>
               <a:defRPr sz="900">
                 <a:solidFill>
-                  <a:srgbClr val="94A3B8"/>
+                  <a:srgbClr val="A1A1AA"/>
                 </a:solidFill>
               </a:defRPr>
             </a:lvl1pPr>
@@ -3101,7 +3101,7 @@
             <a:lvl1pPr>
               <a:defRPr sz="900">
                 <a:solidFill>
-                  <a:srgbClr val="94A3B8"/>
+                  <a:srgbClr val="A1A1AA"/>
                 </a:solidFill>
               </a:defRPr>
             </a:lvl1pPr>
@@ -4037,13 +4037,13 @@
           </a:solidFill>
           <a:ln w="9525">
             <a:solidFill>
-              <a:srgbClr val="E8EDF2"/>
+              <a:srgbClr val="E4E4E7"/>
             </a:solidFill>
             <a:prstDash val="solid"/>
           </a:ln>
           <a:effectLst>
             <a:outerShdw sx="100000" sy="100000" kx="0" ky="0" algn="bl" rotWithShape="0" blurRad="127000" dist="38100" dir="5400000">
-              <a:srgbClr val="0F172A">
+              <a:srgbClr val="18181B">
                 <a:alpha val="10000"/>
               </a:srgbClr>
             </a:outerShdw>
@@ -4104,7 +4104,7 @@
             <a:lvl1pPr>
               <a:defRPr sz="900">
                 <a:solidFill>
-                  <a:srgbClr val="94A3B8"/>
+                  <a:srgbClr val="A1A1AA"/>
                 </a:solidFill>
               </a:defRPr>
             </a:lvl1pPr>
@@ -4200,7 +4200,7 @@
         <p:spPr>
           <a:xfrm>
             <a:off x="658368" y="1920240"/>
-            <a:ext cx="3108960" cy="1152906"/>
+            <a:ext cx="3108960" cy="1047979"/>
           </a:xfrm>
           <a:prstGeom prst="rect">
             <a:avLst/>
@@ -5538,7 +5538,7 @@
             <a:lvl1pPr>
               <a:defRPr sz="900">
                 <a:solidFill>
-                  <a:srgbClr val="94A3B8"/>
+                  <a:srgbClr val="A1A1AA"/>
                 </a:solidFill>
               </a:defRPr>
             </a:lvl1pPr>
@@ -6625,7 +6625,7 @@
             <a:lvl1pPr>
               <a:defRPr sz="900">
                 <a:solidFill>
-                  <a:srgbClr val="94A3B8"/>
+                  <a:srgbClr val="A1A1AA"/>
                 </a:solidFill>
               </a:defRPr>
             </a:lvl1pPr>
@@ -7270,7 +7270,7 @@
             <a:lvl1pPr>
               <a:defRPr sz="900">
                 <a:solidFill>
-                  <a:srgbClr val="94A3B8"/>
+                  <a:srgbClr val="A1A1AA"/>
                 </a:solidFill>
               </a:defRPr>
             </a:lvl1pPr>
@@ -7410,13 +7410,13 @@
           </a:solidFill>
           <a:ln w="9525">
             <a:solidFill>
-              <a:srgbClr val="E8EDF2"/>
+              <a:srgbClr val="E4E4E7"/>
             </a:solidFill>
             <a:prstDash val="solid"/>
           </a:ln>
           <a:effectLst>
             <a:outerShdw sx="100000" sy="100000" kx="0" ky="0" algn="bl" rotWithShape="0" blurRad="127000" dist="38100" dir="5400000">
-              <a:srgbClr val="0F172A">
+              <a:srgbClr val="18181B">
                 <a:alpha val="10000"/>
               </a:srgbClr>
             </a:outerShdw>
@@ -8314,7 +8314,7 @@
             <a:lvl1pPr>
               <a:defRPr sz="900">
                 <a:solidFill>
-                  <a:srgbClr val="94A3B8"/>
+                  <a:srgbClr val="A1A1AA"/>
                 </a:solidFill>
               </a:defRPr>
             </a:lvl1pPr>
@@ -9279,7 +9279,7 @@
             <a:lvl1pPr>
               <a:defRPr sz="900">
                 <a:solidFill>
-                  <a:srgbClr val="94A3B8"/>
+                  <a:srgbClr val="A1A1AA"/>
                 </a:solidFill>
               </a:defRPr>
             </a:lvl1pPr>
@@ -10943,7 +10943,7 @@
             <a:lvl1pPr>
               <a:defRPr sz="900">
                 <a:solidFill>
-                  <a:srgbClr val="94A3B8"/>
+                  <a:srgbClr val="A1A1AA"/>
                 </a:solidFill>
               </a:defRPr>
             </a:lvl1pPr>
@@ -11857,7 +11857,7 @@
             <a:lvl1pPr>
               <a:defRPr sz="900">
                 <a:solidFill>
-                  <a:srgbClr val="94A3B8"/>
+                  <a:srgbClr val="A1A1AA"/>
                 </a:solidFill>
               </a:defRPr>
             </a:lvl1pPr>
@@ -13008,7 +13008,7 @@
             <a:lvl1pPr>
               <a:defRPr sz="900">
                 <a:solidFill>
-                  <a:srgbClr val="94A3B8"/>
+                  <a:srgbClr val="A1A1AA"/>
                 </a:solidFill>
               </a:defRPr>
             </a:lvl1pPr>
@@ -14377,7 +14377,7 @@
             <a:lvl1pPr>
               <a:defRPr sz="900">
                 <a:solidFill>
-                  <a:srgbClr val="94A3B8"/>
+                  <a:srgbClr val="A1A1AA"/>
                 </a:solidFill>
               </a:defRPr>
             </a:lvl1pPr>
@@ -15554,7 +15554,7 @@
             <a:lvl1pPr>
               <a:defRPr sz="900">
                 <a:solidFill>
-                  <a:srgbClr val="94A3B8"/>
+                  <a:srgbClr val="A1A1AA"/>
                 </a:solidFill>
               </a:defRPr>
             </a:lvl1pPr>
@@ -16234,13 +16234,13 @@
           </a:solidFill>
           <a:ln w="9525">
             <a:solidFill>
-              <a:srgbClr val="E8EDF2"/>
+              <a:srgbClr val="E4E4E7"/>
             </a:solidFill>
             <a:prstDash val="solid"/>
           </a:ln>
           <a:effectLst>
             <a:outerShdw sx="100000" sy="100000" kx="0" ky="0" algn="bl" rotWithShape="0" blurRad="127000" dist="38100" dir="5400000">
-              <a:srgbClr val="0F172A">
+              <a:srgbClr val="18181B">
                 <a:alpha val="10000"/>
               </a:srgbClr>
             </a:outerShdw>
@@ -16301,7 +16301,7 @@
             <a:lvl1pPr>
               <a:defRPr sz="900">
                 <a:solidFill>
-                  <a:srgbClr val="94A3B8"/>
+                  <a:srgbClr val="A1A1AA"/>
                 </a:solidFill>
               </a:defRPr>
             </a:lvl1pPr>
@@ -16441,13 +16441,13 @@
           </a:solidFill>
           <a:ln w="9525">
             <a:solidFill>
-              <a:srgbClr val="E8EDF2"/>
+              <a:srgbClr val="E4E4E7"/>
             </a:solidFill>
             <a:prstDash val="solid"/>
           </a:ln>
           <a:effectLst>
             <a:outerShdw sx="100000" sy="100000" kx="0" ky="0" algn="bl" rotWithShape="0" blurRad="127000" dist="38100" dir="5400000">
-              <a:srgbClr val="0F172A">
+              <a:srgbClr val="18181B">
                 <a:alpha val="10000"/>
               </a:srgbClr>
             </a:outerShdw>
@@ -16880,7 +16880,7 @@
             <a:lvl1pPr>
               <a:defRPr sz="900">
                 <a:solidFill>
-                  <a:srgbClr val="94A3B8"/>
+                  <a:srgbClr val="A1A1AA"/>
                 </a:solidFill>
               </a:defRPr>
             </a:lvl1pPr>
@@ -17020,13 +17020,13 @@
           </a:solidFill>
           <a:ln w="9525">
             <a:solidFill>
-              <a:srgbClr val="E8EDF2"/>
+              <a:srgbClr val="E4E4E7"/>
             </a:solidFill>
             <a:prstDash val="solid"/>
           </a:ln>
           <a:effectLst>
             <a:outerShdw sx="100000" sy="100000" kx="0" ky="0" algn="bl" rotWithShape="0" blurRad="127000" dist="38100" dir="5400000">
-              <a:srgbClr val="0F172A">
+              <a:srgbClr val="18181B">
                 <a:alpha val="10000"/>
               </a:srgbClr>
             </a:outerShdw>
@@ -17487,7 +17487,7 @@
             <a:lvl1pPr>
               <a:defRPr sz="900">
                 <a:solidFill>
-                  <a:srgbClr val="94A3B8"/>
+                  <a:srgbClr val="A1A1AA"/>
                 </a:solidFill>
               </a:defRPr>
             </a:lvl1pPr>
@@ -17515,40 +17515,40 @@
   <a:themeElements>
     <a:clrScheme name="Plenara">
       <a:dk1>
-        <a:srgbClr val="0F172A"/>
+        <a:srgbClr val="18181B"/>
       </a:dk1>
       <a:lt1>
         <a:srgbClr val="FFFFFF"/>
       </a:lt1>
       <a:dk2>
-        <a:srgbClr val="0B1220"/>
+        <a:srgbClr val="191E1D"/>
       </a:dk2>
       <a:lt2>
-        <a:srgbClr val="F8FAFC"/>
+        <a:srgbClr val="F4F4F5"/>
       </a:lt2>
       <a:accent1>
-        <a:srgbClr val="0D9488"/>
+        <a:srgbClr val="268478"/>
       </a:accent1>
       <a:accent2>
-        <a:srgbClr val="0F766E"/>
+        <a:srgbClr val="1F7065"/>
       </a:accent2>
       <a:accent3>
-        <a:srgbClr val="64748B"/>
+        <a:srgbClr val="52525B"/>
       </a:accent3>
       <a:accent4>
-        <a:srgbClr val="94A3B8"/>
+        <a:srgbClr val="A1A1AA"/>
       </a:accent4>
       <a:accent5>
-        <a:srgbClr val="F0FDFA"/>
+        <a:srgbClr val="E6F3F1"/>
       </a:accent5>
       <a:accent6>
-        <a:srgbClr val="E2E8F0"/>
+        <a:srgbClr val="E4E4E7"/>
       </a:accent6>
       <a:hlink>
-        <a:srgbClr val="0F766E"/>
+        <a:srgbClr val="29467A"/>
       </a:hlink>
       <a:folHlink>
-        <a:srgbClr val="0F766E"/>
+        <a:srgbClr val="29467A"/>
       </a:folHlink>
     </a:clrScheme>
     <a:fontScheme name="Office">

</xml_diff>

<commit_message>
Präsentationen: Ausbreitungsbild statt entfernter Seite /analytics/ueber, PDF-Fassungen; Bericht Code-Metriken 21.10.
- deck-lib.mjs nimmt für „Ausbreitung“ die Aufnahme ausbreitung-photovoltaik (15.10.2026); screenshots.mjs nimmt die
  Seite /analytics/ueber heraus, die es nicht mehr gibt. Firmenpräsentation neu erzeugt.
- PDF-Fassungen der Firmen- und der Investorenpräsentation.
- requirements/code-metriken-2026-10-21.md: Code-Metriken und statische Analyse auf main ac572476.

Co-Authored-By: Claude Opus 5.5 <noreply@anthropic.com>
</commit_message>
<xml_diff>
--- a/docs/design/praesentation/plenara-firmenpraesentation.pptx
+++ b/docs/design/praesentation/plenara-firmenpraesentation.pptx
@@ -124,7 +124,7 @@
   <p:extLst>
     <p:ext uri="{521415D9-36F7-43E2-AB2F-B90AF26B5E84}">
       <p14:sectionLst xmlns:p14="http://schemas.microsoft.com/office/powerpoint/2010/main">
-        <p14:section name="Plenara" id="{55a6beff-22d2-b696-9ddb-8c2d016b84a0}">
+        <p14:section name="Plenara" id="{63b432c0-2a86-7265-5ebe-9db6062a4aa5}">
           <p14:sldIdLst>
             <p14:sldId id="256"/>
             <p14:sldId id="257"/>
@@ -138,7 +138,7 @@
             <p14:sldId id="265"/>
           </p14:sldIdLst>
         </p14:section>
-        <p14:section name="plenara.X" id="{d194a513-443e-79bc-4873-61fa683a9d13}">
+        <p14:section name="plenara.X" id="{3ac93ea1-49a0-4203-8ba4-dedc6b2b3b81}">
           <p14:sldIdLst>
             <p14:sldId id="266"/>
             <p14:sldId id="267"/>

</xml_diff>